<commit_message>
GRADCAM on streamlit added
</commit_message>
<xml_diff>
--- a/DLREPO.pptx
+++ b/DLREPO.pptx
@@ -7804,10 +7804,10 @@
       </p:sp>
       <p:pic>
         <p:nvPicPr>
-          <p:cNvPr id="15" name="Picture 14">
+          <p:cNvPr id="10" name="Picture 9">
             <a:extLst>
               <a:ext uri="{FF2B5EF4-FFF2-40B4-BE49-F238E27FC236}">
-                <a16:creationId xmlns:a16="http://schemas.microsoft.com/office/drawing/2014/main" id="{19E601FA-18ED-8540-C7E8-1EFA8DEF6A00}"/>
+                <a16:creationId xmlns:a16="http://schemas.microsoft.com/office/drawing/2014/main" id="{B6AE3007-9EF1-A087-9C24-E61FCE7F1910}"/>
               </a:ext>
             </a:extLst>
           </p:cNvPr>
@@ -7824,8 +7824,38 @@
         </p:blipFill>
         <p:spPr>
           <a:xfrm>
-            <a:off x="1188391" y="1350012"/>
-            <a:ext cx="8279787" cy="5191250"/>
+            <a:off x="2019484" y="1287653"/>
+            <a:ext cx="6100457" cy="3427337"/>
+          </a:xfrm>
+          <a:prstGeom prst="rect">
+            <a:avLst/>
+          </a:prstGeom>
+        </p:spPr>
+      </p:pic>
+      <p:pic>
+        <p:nvPicPr>
+          <p:cNvPr id="12" name="Picture 11">
+            <a:extLst>
+              <a:ext uri="{FF2B5EF4-FFF2-40B4-BE49-F238E27FC236}">
+                <a16:creationId xmlns:a16="http://schemas.microsoft.com/office/drawing/2014/main" id="{A88EF6F8-0D88-7E33-96AF-F45819F08B11}"/>
+              </a:ext>
+            </a:extLst>
+          </p:cNvPr>
+          <p:cNvPicPr>
+            <a:picLocks noChangeAspect="1"/>
+          </p:cNvPicPr>
+          <p:nvPr/>
+        </p:nvPicPr>
+        <p:blipFill>
+          <a:blip r:embed="rId5"/>
+          <a:stretch>
+            <a:fillRect/>
+          </a:stretch>
+        </p:blipFill>
+        <p:spPr>
+          <a:xfrm>
+            <a:off x="2029212" y="4714990"/>
+            <a:ext cx="6100457" cy="2362529"/>
           </a:xfrm>
           <a:prstGeom prst="rect">
             <a:avLst/>

</xml_diff>